<commit_message>
Update lesson 01 slides; add bibliography; finalize GitHub setup
- lessons/01/01-intro.{md,html,pptx}: slide content updates
- .gitignore: stop ignoring .vscode/ (settings.json is tracked)
- bibliography/00_bibliography_24_25.md: previous-year list as starting point

Co-Authored-By: Claude Opus 4.8 <noreply@anthropic.com>
</commit_message>
<xml_diff>
--- a/lessons/01/01-intro.pptx
+++ b/lessons/01/01-intro.pptx
@@ -21,9 +21,16 @@
     <p:sldId id="269" r:id="rId15"/>
     <p:sldId id="270" r:id="rId16"/>
     <p:sldId id="271" r:id="rId17"/>
+    <p:sldId id="272" r:id="rId18"/>
+    <p:sldId id="273" r:id="rId19"/>
+    <p:sldId id="274" r:id="rId20"/>
+    <p:sldId id="275" r:id="rId21"/>
+    <p:sldId id="276" r:id="rId22"/>
+    <p:sldId id="277" r:id="rId23"/>
+    <p:sldId id="278" r:id="rId24"/>
   </p:sldIdLst>
   <p:notesMasterIdLst>
-    <p:notesMasterId r:id="rId18"/>
+    <p:notesMasterId r:id="rId25"/>
   </p:notesMasterIdLst>
   <p:sldSz cx="12192000" cy="6858000"/>
   <p:notesSz cx="6858000" cy="12192000"/>
@@ -605,7 +612,7 @@
           <a:p>
             <a:r>
               <a:rPr lang="en-US" dirty="0"/>
-              <a:t/>
+              <a:t>- While it may feel counterintuitive, a lot of what is deemed tedious or boring work things like literature review, data cleaning, virtual enviroment setups, boilerplate code, etc...  is often just as important and can lead to crucial insights that feed other parts of the work.</a:t>
             </a:r>
             <a:endParaRPr lang="en-US" dirty="0"/>
           </a:p>
@@ -693,7 +700,7 @@
           <a:p>
             <a:r>
               <a:rPr lang="en-US" dirty="0"/>
-              <a:t>- What we'll cover on this topic today assumes a degree of basic familiarity with Project Management, based on some of your feedback via the questionnaire.</a:t>
+              <a:t/>
             </a:r>
             <a:endParaRPr lang="en-US" dirty="0"/>
           </a:p>
@@ -869,7 +876,7 @@
           <a:p>
             <a:r>
               <a:rPr lang="en-US" dirty="0"/>
-              <a:t/>
+              <a:t>- What we'll cover on this topic today assumes a degree of basic familiarity with Project Management, based on some of your feedback via the questionnaire.</a:t>
             </a:r>
             <a:endParaRPr lang="en-US" dirty="0"/>
           </a:p>
@@ -1045,7 +1052,7 @@
           <a:p>
             <a:r>
               <a:rPr lang="en-US" dirty="0"/>
-              <a:t>- It's totally normal to make mistakes at the planning stage, to forget something, or get it wrong. No plan is perfect, it's having it and learning through doing it over and over that matters.</a:t>
+              <a:t/>
             </a:r>
             <a:endParaRPr lang="en-US" dirty="0"/>
           </a:p>
@@ -1157,6 +1164,270 @@
             <a:fld id="{F7021451-1387-4CA6-816F-3879F97B5CBC}" type="slidenum">
               <a:rPr lang="en-US"/>
               <a:t>16</a:t>
+            </a:fld>
+            <a:endParaRPr lang="en-US"/>
+          </a:p>
+        </p:txBody>
+      </p:sp>
+    </p:spTree>
+    <p:extLst>
+      <p:ext uri="{BB962C8B-B14F-4D97-AF65-F5344CB8AC3E}">
+        <p14:creationId xmlns:p14="http://schemas.microsoft.com/office/powerpoint/2010/main" val="1024086991"/>
+      </p:ext>
+    </p:extLst>
+  </p:cSld>
+  <p:clrMapOvr>
+    <a:masterClrMapping/>
+  </p:clrMapOvr>
+</p:notes>
+</file>
+
+<file path=ppt/notesSlides/notesSlide17.xml><?xml version="1.0" encoding="utf-8"?>
+<p:notes xmlns:a="http://schemas.openxmlformats.org/drawingml/2006/main" xmlns:r="http://schemas.openxmlformats.org/officeDocument/2006/relationships" xmlns:p="http://schemas.openxmlformats.org/presentationml/2006/main">
+  <p:cSld>
+    <p:spTree>
+      <p:nvGrpSpPr>
+        <p:cNvPr id="1" name=""/>
+        <p:cNvGrpSpPr/>
+        <p:nvPr/>
+      </p:nvGrpSpPr>
+      <p:grpSpPr>
+        <a:xfrm>
+          <a:off x="0" y="0"/>
+          <a:ext cx="0" cy="0"/>
+          <a:chOff x="0" y="0"/>
+          <a:chExt cx="0" cy="0"/>
+        </a:xfrm>
+      </p:grpSpPr>
+      <p:sp>
+        <p:nvSpPr>
+          <p:cNvPr id="2" name="Slide Image Placeholder 1"/>
+          <p:cNvSpPr>
+            <a:spLocks noGrp="1" noRot="1" noChangeAspect="1"/>
+          </p:cNvSpPr>
+          <p:nvPr>
+            <p:ph type="sldImg"/>
+          </p:nvPr>
+        </p:nvSpPr>
+        <p:spPr/>
+      </p:sp>
+      <p:sp>
+        <p:nvSpPr>
+          <p:cNvPr id="3" name="Notes Placeholder 2"/>
+          <p:cNvSpPr>
+            <a:spLocks noGrp="1"/>
+          </p:cNvSpPr>
+          <p:nvPr>
+            <p:ph type="body" idx="1"/>
+          </p:nvPr>
+        </p:nvSpPr>
+        <p:spPr/>
+        <p:txBody>
+          <a:bodyPr/>
+          <a:lstStyle/>
+          <a:p>
+            <a:r>
+              <a:rPr lang="en-US" dirty="0"/>
+              <a:t>- It's totally normal to make mistakes at the planning stage, to forget something, or get it wrong. No plan is perfect, it's having it and learning through doing it over and over that matters. It's a way of laying out all the questions you have, and if you can already include answers great, otherwise at least you know you need that answer.</a:t>
+            </a:r>
+            <a:endParaRPr lang="en-US" dirty="0"/>
+          </a:p>
+        </p:txBody>
+      </p:sp>
+      <p:sp>
+        <p:nvSpPr>
+          <p:cNvPr id="4" name="Slide Number Placeholder 3"/>
+          <p:cNvSpPr>
+            <a:spLocks noGrp="1"/>
+          </p:cNvSpPr>
+          <p:nvPr>
+            <p:ph type="sldNum" sz="quarter" idx="10"/>
+          </p:nvPr>
+        </p:nvSpPr>
+        <p:spPr/>
+        <p:txBody>
+          <a:bodyPr/>
+          <a:lstStyle/>
+          <a:p>
+            <a:fld id="{F7021451-1387-4CA6-816F-3879F97B5CBC}" type="slidenum">
+              <a:rPr lang="en-US"/>
+              <a:t>17</a:t>
+            </a:fld>
+            <a:endParaRPr lang="en-US"/>
+          </a:p>
+        </p:txBody>
+      </p:sp>
+    </p:spTree>
+    <p:extLst>
+      <p:ext uri="{BB962C8B-B14F-4D97-AF65-F5344CB8AC3E}">
+        <p14:creationId xmlns:p14="http://schemas.microsoft.com/office/powerpoint/2010/main" val="1024086991"/>
+      </p:ext>
+    </p:extLst>
+  </p:cSld>
+  <p:clrMapOvr>
+    <a:masterClrMapping/>
+  </p:clrMapOvr>
+</p:notes>
+</file>
+
+<file path=ppt/notesSlides/notesSlide18.xml><?xml version="1.0" encoding="utf-8"?>
+<p:notes xmlns:a="http://schemas.openxmlformats.org/drawingml/2006/main" xmlns:r="http://schemas.openxmlformats.org/officeDocument/2006/relationships" xmlns:p="http://schemas.openxmlformats.org/presentationml/2006/main">
+  <p:cSld>
+    <p:spTree>
+      <p:nvGrpSpPr>
+        <p:cNvPr id="1" name=""/>
+        <p:cNvGrpSpPr/>
+        <p:nvPr/>
+      </p:nvGrpSpPr>
+      <p:grpSpPr>
+        <a:xfrm>
+          <a:off x="0" y="0"/>
+          <a:ext cx="0" cy="0"/>
+          <a:chOff x="0" y="0"/>
+          <a:chExt cx="0" cy="0"/>
+        </a:xfrm>
+      </p:grpSpPr>
+      <p:sp>
+        <p:nvSpPr>
+          <p:cNvPr id="2" name="Slide Image Placeholder 1"/>
+          <p:cNvSpPr>
+            <a:spLocks noGrp="1" noRot="1" noChangeAspect="1"/>
+          </p:cNvSpPr>
+          <p:nvPr>
+            <p:ph type="sldImg"/>
+          </p:nvPr>
+        </p:nvSpPr>
+        <p:spPr/>
+      </p:sp>
+      <p:sp>
+        <p:nvSpPr>
+          <p:cNvPr id="3" name="Notes Placeholder 2"/>
+          <p:cNvSpPr>
+            <a:spLocks noGrp="1"/>
+          </p:cNvSpPr>
+          <p:nvPr>
+            <p:ph type="body" idx="1"/>
+          </p:nvPr>
+        </p:nvSpPr>
+        <p:spPr/>
+        <p:txBody>
+          <a:bodyPr/>
+          <a:lstStyle/>
+          <a:p>
+            <a:r>
+              <a:rPr lang="en-US" dirty="0"/>
+              <a:t/>
+            </a:r>
+            <a:endParaRPr lang="en-US" dirty="0"/>
+          </a:p>
+        </p:txBody>
+      </p:sp>
+      <p:sp>
+        <p:nvSpPr>
+          <p:cNvPr id="4" name="Slide Number Placeholder 3"/>
+          <p:cNvSpPr>
+            <a:spLocks noGrp="1"/>
+          </p:cNvSpPr>
+          <p:nvPr>
+            <p:ph type="sldNum" sz="quarter" idx="10"/>
+          </p:nvPr>
+        </p:nvSpPr>
+        <p:spPr/>
+        <p:txBody>
+          <a:bodyPr/>
+          <a:lstStyle/>
+          <a:p>
+            <a:fld id="{F7021451-1387-4CA6-816F-3879F97B5CBC}" type="slidenum">
+              <a:rPr lang="en-US"/>
+              <a:t>18</a:t>
+            </a:fld>
+            <a:endParaRPr lang="en-US"/>
+          </a:p>
+        </p:txBody>
+      </p:sp>
+    </p:spTree>
+    <p:extLst>
+      <p:ext uri="{BB962C8B-B14F-4D97-AF65-F5344CB8AC3E}">
+        <p14:creationId xmlns:p14="http://schemas.microsoft.com/office/powerpoint/2010/main" val="1024086991"/>
+      </p:ext>
+    </p:extLst>
+  </p:cSld>
+  <p:clrMapOvr>
+    <a:masterClrMapping/>
+  </p:clrMapOvr>
+</p:notes>
+</file>
+
+<file path=ppt/notesSlides/notesSlide19.xml><?xml version="1.0" encoding="utf-8"?>
+<p:notes xmlns:a="http://schemas.openxmlformats.org/drawingml/2006/main" xmlns:r="http://schemas.openxmlformats.org/officeDocument/2006/relationships" xmlns:p="http://schemas.openxmlformats.org/presentationml/2006/main">
+  <p:cSld>
+    <p:spTree>
+      <p:nvGrpSpPr>
+        <p:cNvPr id="1" name=""/>
+        <p:cNvGrpSpPr/>
+        <p:nvPr/>
+      </p:nvGrpSpPr>
+      <p:grpSpPr>
+        <a:xfrm>
+          <a:off x="0" y="0"/>
+          <a:ext cx="0" cy="0"/>
+          <a:chOff x="0" y="0"/>
+          <a:chExt cx="0" cy="0"/>
+        </a:xfrm>
+      </p:grpSpPr>
+      <p:sp>
+        <p:nvSpPr>
+          <p:cNvPr id="2" name="Slide Image Placeholder 1"/>
+          <p:cNvSpPr>
+            <a:spLocks noGrp="1" noRot="1" noChangeAspect="1"/>
+          </p:cNvSpPr>
+          <p:nvPr>
+            <p:ph type="sldImg"/>
+          </p:nvPr>
+        </p:nvSpPr>
+        <p:spPr/>
+      </p:sp>
+      <p:sp>
+        <p:nvSpPr>
+          <p:cNvPr id="3" name="Notes Placeholder 2"/>
+          <p:cNvSpPr>
+            <a:spLocks noGrp="1"/>
+          </p:cNvSpPr>
+          <p:nvPr>
+            <p:ph type="body" idx="1"/>
+          </p:nvPr>
+        </p:nvSpPr>
+        <p:spPr/>
+        <p:txBody>
+          <a:bodyPr/>
+          <a:lstStyle/>
+          <a:p>
+            <a:r>
+              <a:rPr lang="en-US" dirty="0"/>
+              <a:t>- I'll show you some real world budgets in a bit, so you can get a sense of what time and budget mean practicaly.</a:t>
+            </a:r>
+            <a:endParaRPr lang="en-US" dirty="0"/>
+          </a:p>
+        </p:txBody>
+      </p:sp>
+      <p:sp>
+        <p:nvSpPr>
+          <p:cNvPr id="4" name="Slide Number Placeholder 3"/>
+          <p:cNvSpPr>
+            <a:spLocks noGrp="1"/>
+          </p:cNvSpPr>
+          <p:nvPr>
+            <p:ph type="sldNum" sz="quarter" idx="10"/>
+          </p:nvPr>
+        </p:nvSpPr>
+        <p:spPr/>
+        <p:txBody>
+          <a:bodyPr/>
+          <a:lstStyle/>
+          <a:p>
+            <a:fld id="{F7021451-1387-4CA6-816F-3879F97B5CBC}" type="slidenum">
+              <a:rPr lang="en-US"/>
+              <a:t>19</a:t>
             </a:fld>
             <a:endParaRPr lang="en-US"/>
           </a:p>
@@ -1265,7 +1536,7 @@
 </p:notes>
 </file>
 
-<file path=ppt/notesSlides/notesSlide3.xml><?xml version="1.0" encoding="utf-8"?>
+<file path=ppt/notesSlides/notesSlide20.xml><?xml version="1.0" encoding="utf-8"?>
 <p:notes xmlns:a="http://schemas.openxmlformats.org/drawingml/2006/main" xmlns:r="http://schemas.openxmlformats.org/officeDocument/2006/relationships" xmlns:p="http://schemas.openxmlformats.org/presentationml/2006/main">
   <p:cSld>
     <p:spTree>
@@ -1334,7 +1605,7 @@
           <a:p>
             <a:fld id="{F7021451-1387-4CA6-816F-3879F97B5CBC}" type="slidenum">
               <a:rPr lang="en-US"/>
-              <a:t>3</a:t>
+              <a:t>20</a:t>
             </a:fld>
             <a:endParaRPr lang="en-US"/>
           </a:p>
@@ -1353,7 +1624,96 @@
 </p:notes>
 </file>
 
-<file path=ppt/notesSlides/notesSlide4.xml><?xml version="1.0" encoding="utf-8"?>
+<file path=ppt/notesSlides/notesSlide21.xml><?xml version="1.0" encoding="utf-8"?>
+<p:notes xmlns:a="http://schemas.openxmlformats.org/drawingml/2006/main" xmlns:r="http://schemas.openxmlformats.org/officeDocument/2006/relationships" xmlns:p="http://schemas.openxmlformats.org/presentationml/2006/main">
+  <p:cSld>
+    <p:spTree>
+      <p:nvGrpSpPr>
+        <p:cNvPr id="1" name=""/>
+        <p:cNvGrpSpPr/>
+        <p:nvPr/>
+      </p:nvGrpSpPr>
+      <p:grpSpPr>
+        <a:xfrm>
+          <a:off x="0" y="0"/>
+          <a:ext cx="0" cy="0"/>
+          <a:chOff x="0" y="0"/>
+          <a:chExt cx="0" cy="0"/>
+        </a:xfrm>
+      </p:grpSpPr>
+      <p:sp>
+        <p:nvSpPr>
+          <p:cNvPr id="2" name="Slide Image Placeholder 1"/>
+          <p:cNvSpPr>
+            <a:spLocks noGrp="1" noRot="1" noChangeAspect="1"/>
+          </p:cNvSpPr>
+          <p:nvPr>
+            <p:ph type="sldImg"/>
+          </p:nvPr>
+        </p:nvSpPr>
+        <p:spPr/>
+      </p:sp>
+      <p:sp>
+        <p:nvSpPr>
+          <p:cNvPr id="3" name="Notes Placeholder 2"/>
+          <p:cNvSpPr>
+            <a:spLocks noGrp="1"/>
+          </p:cNvSpPr>
+          <p:nvPr>
+            <p:ph type="body" idx="1"/>
+          </p:nvPr>
+        </p:nvSpPr>
+        <p:spPr/>
+        <p:txBody>
+          <a:bodyPr/>
+          <a:lstStyle/>
+          <a:p>
+            <a:r>
+              <a:rPr lang="en-US" dirty="0"/>
+              <a:t>- Slack, Notion, Discord, Zoom, shared calendars, Trello, Figma, etc.
+- Sometimes it's better for one person to take something on rather than collaborate, as long as they communicate what is happening to others.</a:t>
+            </a:r>
+            <a:endParaRPr lang="en-US" dirty="0"/>
+          </a:p>
+        </p:txBody>
+      </p:sp>
+      <p:sp>
+        <p:nvSpPr>
+          <p:cNvPr id="4" name="Slide Number Placeholder 3"/>
+          <p:cNvSpPr>
+            <a:spLocks noGrp="1"/>
+          </p:cNvSpPr>
+          <p:nvPr>
+            <p:ph type="sldNum" sz="quarter" idx="10"/>
+          </p:nvPr>
+        </p:nvSpPr>
+        <p:spPr/>
+        <p:txBody>
+          <a:bodyPr/>
+          <a:lstStyle/>
+          <a:p>
+            <a:fld id="{F7021451-1387-4CA6-816F-3879F97B5CBC}" type="slidenum">
+              <a:rPr lang="en-US"/>
+              <a:t>21</a:t>
+            </a:fld>
+            <a:endParaRPr lang="en-US"/>
+          </a:p>
+        </p:txBody>
+      </p:sp>
+    </p:spTree>
+    <p:extLst>
+      <p:ext uri="{BB962C8B-B14F-4D97-AF65-F5344CB8AC3E}">
+        <p14:creationId xmlns:p14="http://schemas.microsoft.com/office/powerpoint/2010/main" val="1024086991"/>
+      </p:ext>
+    </p:extLst>
+  </p:cSld>
+  <p:clrMapOvr>
+    <a:masterClrMapping/>
+  </p:clrMapOvr>
+</p:notes>
+</file>
+
+<file path=ppt/notesSlides/notesSlide22.xml><?xml version="1.0" encoding="utf-8"?>
 <p:notes xmlns:a="http://schemas.openxmlformats.org/drawingml/2006/main" xmlns:r="http://schemas.openxmlformats.org/officeDocument/2006/relationships" xmlns:p="http://schemas.openxmlformats.org/presentationml/2006/main">
   <p:cSld>
     <p:spTree>
@@ -1422,7 +1782,7 @@
           <a:p>
             <a:fld id="{F7021451-1387-4CA6-816F-3879F97B5CBC}" type="slidenum">
               <a:rPr lang="en-US"/>
-              <a:t>4</a:t>
+              <a:t>22</a:t>
             </a:fld>
             <a:endParaRPr lang="en-US"/>
           </a:p>
@@ -1441,7 +1801,7 @@
 </p:notes>
 </file>
 
-<file path=ppt/notesSlides/notesSlide5.xml><?xml version="1.0" encoding="utf-8"?>
+<file path=ppt/notesSlides/notesSlide23.xml><?xml version="1.0" encoding="utf-8"?>
 <p:notes xmlns:a="http://schemas.openxmlformats.org/drawingml/2006/main" xmlns:r="http://schemas.openxmlformats.org/officeDocument/2006/relationships" xmlns:p="http://schemas.openxmlformats.org/presentationml/2006/main">
   <p:cSld>
     <p:spTree>
@@ -1510,7 +1870,7 @@
           <a:p>
             <a:fld id="{F7021451-1387-4CA6-816F-3879F97B5CBC}" type="slidenum">
               <a:rPr lang="en-US"/>
-              <a:t>5</a:t>
+              <a:t>23</a:t>
             </a:fld>
             <a:endParaRPr lang="en-US"/>
           </a:p>
@@ -1529,6 +1889,270 @@
 </p:notes>
 </file>
 
+<file path=ppt/notesSlides/notesSlide3.xml><?xml version="1.0" encoding="utf-8"?>
+<p:notes xmlns:a="http://schemas.openxmlformats.org/drawingml/2006/main" xmlns:r="http://schemas.openxmlformats.org/officeDocument/2006/relationships" xmlns:p="http://schemas.openxmlformats.org/presentationml/2006/main">
+  <p:cSld>
+    <p:spTree>
+      <p:nvGrpSpPr>
+        <p:cNvPr id="1" name=""/>
+        <p:cNvGrpSpPr/>
+        <p:nvPr/>
+      </p:nvGrpSpPr>
+      <p:grpSpPr>
+        <a:xfrm>
+          <a:off x="0" y="0"/>
+          <a:ext cx="0" cy="0"/>
+          <a:chOff x="0" y="0"/>
+          <a:chExt cx="0" cy="0"/>
+        </a:xfrm>
+      </p:grpSpPr>
+      <p:sp>
+        <p:nvSpPr>
+          <p:cNvPr id="2" name="Slide Image Placeholder 1"/>
+          <p:cNvSpPr>
+            <a:spLocks noGrp="1" noRot="1" noChangeAspect="1"/>
+          </p:cNvSpPr>
+          <p:nvPr>
+            <p:ph type="sldImg"/>
+          </p:nvPr>
+        </p:nvSpPr>
+        <p:spPr/>
+      </p:sp>
+      <p:sp>
+        <p:nvSpPr>
+          <p:cNvPr id="3" name="Notes Placeholder 2"/>
+          <p:cNvSpPr>
+            <a:spLocks noGrp="1"/>
+          </p:cNvSpPr>
+          <p:nvPr>
+            <p:ph type="body" idx="1"/>
+          </p:nvPr>
+        </p:nvSpPr>
+        <p:spPr/>
+        <p:txBody>
+          <a:bodyPr/>
+          <a:lstStyle/>
+          <a:p>
+            <a:r>
+              <a:rPr lang="en-US" dirty="0"/>
+              <a:t/>
+            </a:r>
+            <a:endParaRPr lang="en-US" dirty="0"/>
+          </a:p>
+        </p:txBody>
+      </p:sp>
+      <p:sp>
+        <p:nvSpPr>
+          <p:cNvPr id="4" name="Slide Number Placeholder 3"/>
+          <p:cNvSpPr>
+            <a:spLocks noGrp="1"/>
+          </p:cNvSpPr>
+          <p:nvPr>
+            <p:ph type="sldNum" sz="quarter" idx="10"/>
+          </p:nvPr>
+        </p:nvSpPr>
+        <p:spPr/>
+        <p:txBody>
+          <a:bodyPr/>
+          <a:lstStyle/>
+          <a:p>
+            <a:fld id="{F7021451-1387-4CA6-816F-3879F97B5CBC}" type="slidenum">
+              <a:rPr lang="en-US"/>
+              <a:t>3</a:t>
+            </a:fld>
+            <a:endParaRPr lang="en-US"/>
+          </a:p>
+        </p:txBody>
+      </p:sp>
+    </p:spTree>
+    <p:extLst>
+      <p:ext uri="{BB962C8B-B14F-4D97-AF65-F5344CB8AC3E}">
+        <p14:creationId xmlns:p14="http://schemas.microsoft.com/office/powerpoint/2010/main" val="1024086991"/>
+      </p:ext>
+    </p:extLst>
+  </p:cSld>
+  <p:clrMapOvr>
+    <a:masterClrMapping/>
+  </p:clrMapOvr>
+</p:notes>
+</file>
+
+<file path=ppt/notesSlides/notesSlide4.xml><?xml version="1.0" encoding="utf-8"?>
+<p:notes xmlns:a="http://schemas.openxmlformats.org/drawingml/2006/main" xmlns:r="http://schemas.openxmlformats.org/officeDocument/2006/relationships" xmlns:p="http://schemas.openxmlformats.org/presentationml/2006/main">
+  <p:cSld>
+    <p:spTree>
+      <p:nvGrpSpPr>
+        <p:cNvPr id="1" name=""/>
+        <p:cNvGrpSpPr/>
+        <p:nvPr/>
+      </p:nvGrpSpPr>
+      <p:grpSpPr>
+        <a:xfrm>
+          <a:off x="0" y="0"/>
+          <a:ext cx="0" cy="0"/>
+          <a:chOff x="0" y="0"/>
+          <a:chExt cx="0" cy="0"/>
+        </a:xfrm>
+      </p:grpSpPr>
+      <p:sp>
+        <p:nvSpPr>
+          <p:cNvPr id="2" name="Slide Image Placeholder 1"/>
+          <p:cNvSpPr>
+            <a:spLocks noGrp="1" noRot="1" noChangeAspect="1"/>
+          </p:cNvSpPr>
+          <p:nvPr>
+            <p:ph type="sldImg"/>
+          </p:nvPr>
+        </p:nvSpPr>
+        <p:spPr/>
+      </p:sp>
+      <p:sp>
+        <p:nvSpPr>
+          <p:cNvPr id="3" name="Notes Placeholder 2"/>
+          <p:cNvSpPr>
+            <a:spLocks noGrp="1"/>
+          </p:cNvSpPr>
+          <p:nvPr>
+            <p:ph type="body" idx="1"/>
+          </p:nvPr>
+        </p:nvSpPr>
+        <p:spPr/>
+        <p:txBody>
+          <a:bodyPr/>
+          <a:lstStyle/>
+          <a:p>
+            <a:r>
+              <a:rPr lang="en-US" dirty="0"/>
+              <a:t/>
+            </a:r>
+            <a:endParaRPr lang="en-US" dirty="0"/>
+          </a:p>
+        </p:txBody>
+      </p:sp>
+      <p:sp>
+        <p:nvSpPr>
+          <p:cNvPr id="4" name="Slide Number Placeholder 3"/>
+          <p:cNvSpPr>
+            <a:spLocks noGrp="1"/>
+          </p:cNvSpPr>
+          <p:nvPr>
+            <p:ph type="sldNum" sz="quarter" idx="10"/>
+          </p:nvPr>
+        </p:nvSpPr>
+        <p:spPr/>
+        <p:txBody>
+          <a:bodyPr/>
+          <a:lstStyle/>
+          <a:p>
+            <a:fld id="{F7021451-1387-4CA6-816F-3879F97B5CBC}" type="slidenum">
+              <a:rPr lang="en-US"/>
+              <a:t>4</a:t>
+            </a:fld>
+            <a:endParaRPr lang="en-US"/>
+          </a:p>
+        </p:txBody>
+      </p:sp>
+    </p:spTree>
+    <p:extLst>
+      <p:ext uri="{BB962C8B-B14F-4D97-AF65-F5344CB8AC3E}">
+        <p14:creationId xmlns:p14="http://schemas.microsoft.com/office/powerpoint/2010/main" val="1024086991"/>
+      </p:ext>
+    </p:extLst>
+  </p:cSld>
+  <p:clrMapOvr>
+    <a:masterClrMapping/>
+  </p:clrMapOvr>
+</p:notes>
+</file>
+
+<file path=ppt/notesSlides/notesSlide5.xml><?xml version="1.0" encoding="utf-8"?>
+<p:notes xmlns:a="http://schemas.openxmlformats.org/drawingml/2006/main" xmlns:r="http://schemas.openxmlformats.org/officeDocument/2006/relationships" xmlns:p="http://schemas.openxmlformats.org/presentationml/2006/main">
+  <p:cSld>
+    <p:spTree>
+      <p:nvGrpSpPr>
+        <p:cNvPr id="1" name=""/>
+        <p:cNvGrpSpPr/>
+        <p:nvPr/>
+      </p:nvGrpSpPr>
+      <p:grpSpPr>
+        <a:xfrm>
+          <a:off x="0" y="0"/>
+          <a:ext cx="0" cy="0"/>
+          <a:chOff x="0" y="0"/>
+          <a:chExt cx="0" cy="0"/>
+        </a:xfrm>
+      </p:grpSpPr>
+      <p:sp>
+        <p:nvSpPr>
+          <p:cNvPr id="2" name="Slide Image Placeholder 1"/>
+          <p:cNvSpPr>
+            <a:spLocks noGrp="1" noRot="1" noChangeAspect="1"/>
+          </p:cNvSpPr>
+          <p:nvPr>
+            <p:ph type="sldImg"/>
+          </p:nvPr>
+        </p:nvSpPr>
+        <p:spPr/>
+      </p:sp>
+      <p:sp>
+        <p:nvSpPr>
+          <p:cNvPr id="3" name="Notes Placeholder 2"/>
+          <p:cNvSpPr>
+            <a:spLocks noGrp="1"/>
+          </p:cNvSpPr>
+          <p:nvPr>
+            <p:ph type="body" idx="1"/>
+          </p:nvPr>
+        </p:nvSpPr>
+        <p:spPr/>
+        <p:txBody>
+          <a:bodyPr/>
+          <a:lstStyle/>
+          <a:p>
+            <a:r>
+              <a:rPr lang="en-US" dirty="0"/>
+              <a:t/>
+            </a:r>
+            <a:endParaRPr lang="en-US" dirty="0"/>
+          </a:p>
+        </p:txBody>
+      </p:sp>
+      <p:sp>
+        <p:nvSpPr>
+          <p:cNvPr id="4" name="Slide Number Placeholder 3"/>
+          <p:cNvSpPr>
+            <a:spLocks noGrp="1"/>
+          </p:cNvSpPr>
+          <p:nvPr>
+            <p:ph type="sldNum" sz="quarter" idx="10"/>
+          </p:nvPr>
+        </p:nvSpPr>
+        <p:spPr/>
+        <p:txBody>
+          <a:bodyPr/>
+          <a:lstStyle/>
+          <a:p>
+            <a:fld id="{F7021451-1387-4CA6-816F-3879F97B5CBC}" type="slidenum">
+              <a:rPr lang="en-US"/>
+              <a:t>5</a:t>
+            </a:fld>
+            <a:endParaRPr lang="en-US"/>
+          </a:p>
+        </p:txBody>
+      </p:sp>
+    </p:spTree>
+    <p:extLst>
+      <p:ext uri="{BB962C8B-B14F-4D97-AF65-F5344CB8AC3E}">
+        <p14:creationId xmlns:p14="http://schemas.microsoft.com/office/powerpoint/2010/main" val="1024086991"/>
+      </p:ext>
+    </p:extLst>
+  </p:cSld>
+  <p:clrMapOvr>
+    <a:masterClrMapping/>
+  </p:clrMapOvr>
+</p:notes>
+</file>
+
 <file path=ppt/notesSlides/notesSlide6.xml><?xml version="1.0" encoding="utf-8"?>
 <p:notes xmlns:a="http://schemas.openxmlformats.org/drawingml/2006/main" xmlns:r="http://schemas.openxmlformats.org/officeDocument/2006/relationships" xmlns:p="http://schemas.openxmlformats.org/presentationml/2006/main">
   <p:cSld>
@@ -1663,7 +2287,7 @@
           <a:p>
             <a:r>
               <a:rPr lang="en-US" dirty="0"/>
-              <a:t>- Another way to look at this is that while GenAI does simplify things, if you choose to use it so, it also complicates others, whether that be your own learning or the need to manage it.</a:t>
+              <a:t/>
             </a:r>
             <a:endParaRPr lang="en-US" dirty="0"/>
           </a:p>
@@ -1751,7 +2375,7 @@
           <a:p>
             <a:r>
               <a:rPr lang="en-US" dirty="0"/>
-              <a:t>- It's one thing to wave away the implications of having something delivered to you the next day. It's another waving away the implications of generating images, audio, video, or text with a few lines of text in seconds. The immediacy of it feeds the burden.</a:t>
+              <a:t>- Another way to look at this is that while GenAI does simplify things, if you choose to use it so, it also complicates others, whether that be your own learning or the need to manage it.</a:t>
             </a:r>
             <a:endParaRPr lang="en-US" dirty="0"/>
           </a:p>
@@ -1839,7 +2463,7 @@
           <a:p>
             <a:r>
               <a:rPr lang="en-US" dirty="0"/>
-              <a:t/>
+              <a:t>- It's one thing to wave away the implications of having something delivered to you the next day. It's another waving away the implications of generating images, audio, video, or text with a few lines of text in seconds. The immediacy of it feeds the burden.</a:t>
             </a:r>
             <a:endParaRPr lang="en-US" dirty="0"/>
           </a:p>
@@ -2500,9 +3124,282 @@
 </p:sld>
 </file>
 
+<file path=ppt/slides/slide17.xml><?xml version="1.0" encoding="utf-8"?>
+<p:sld xmlns:a="http://schemas.openxmlformats.org/drawingml/2006/main" xmlns:r="http://schemas.openxmlformats.org/officeDocument/2006/relationships" xmlns:p="http://schemas.openxmlformats.org/presentationml/2006/main">
+  <p:cSld name="Slide 17">
+    <p:bg>
+      <p:bgPr>
+        <a:blipFill dpi="0" rotWithShape="1">
+          <a:blip r:embed="rId1">
+            <a:lum/>
+          </a:blip>
+          <a:srcRect/>
+          <a:stretch>
+            <a:fillRect/>
+          </a:stretch>
+        </a:blipFill>
+        <a:effectLst/>
+      </p:bgPr>
+    </p:bg>
+    <p:spTree>
+      <p:nvGrpSpPr>
+        <p:cNvPr id="1" name=""/>
+        <p:cNvGrpSpPr/>
+        <p:nvPr/>
+      </p:nvGrpSpPr>
+      <p:grpSpPr>
+        <a:xfrm>
+          <a:off x="0" y="0"/>
+          <a:ext cx="0" cy="0"/>
+          <a:chOff x="0" y="0"/>
+          <a:chExt cx="0" cy="0"/>
+        </a:xfrm>
+      </p:grpSpPr>
+    </p:spTree>
+  </p:cSld>
+  <p:clrMapOvr>
+    <a:masterClrMapping/>
+  </p:clrMapOvr>
+</p:sld>
+</file>
+
+<file path=ppt/slides/slide18.xml><?xml version="1.0" encoding="utf-8"?>
+<p:sld xmlns:a="http://schemas.openxmlformats.org/drawingml/2006/main" xmlns:r="http://schemas.openxmlformats.org/officeDocument/2006/relationships" xmlns:p="http://schemas.openxmlformats.org/presentationml/2006/main">
+  <p:cSld name="Slide 18">
+    <p:bg>
+      <p:bgPr>
+        <a:blipFill dpi="0" rotWithShape="1">
+          <a:blip r:embed="rId1">
+            <a:lum/>
+          </a:blip>
+          <a:srcRect/>
+          <a:stretch>
+            <a:fillRect/>
+          </a:stretch>
+        </a:blipFill>
+        <a:effectLst/>
+      </p:bgPr>
+    </p:bg>
+    <p:spTree>
+      <p:nvGrpSpPr>
+        <p:cNvPr id="1" name=""/>
+        <p:cNvGrpSpPr/>
+        <p:nvPr/>
+      </p:nvGrpSpPr>
+      <p:grpSpPr>
+        <a:xfrm>
+          <a:off x="0" y="0"/>
+          <a:ext cx="0" cy="0"/>
+          <a:chOff x="0" y="0"/>
+          <a:chExt cx="0" cy="0"/>
+        </a:xfrm>
+      </p:grpSpPr>
+    </p:spTree>
+  </p:cSld>
+  <p:clrMapOvr>
+    <a:masterClrMapping/>
+  </p:clrMapOvr>
+</p:sld>
+</file>
+
+<file path=ppt/slides/slide19.xml><?xml version="1.0" encoding="utf-8"?>
+<p:sld xmlns:a="http://schemas.openxmlformats.org/drawingml/2006/main" xmlns:r="http://schemas.openxmlformats.org/officeDocument/2006/relationships" xmlns:p="http://schemas.openxmlformats.org/presentationml/2006/main">
+  <p:cSld name="Slide 19">
+    <p:bg>
+      <p:bgPr>
+        <a:blipFill dpi="0" rotWithShape="1">
+          <a:blip r:embed="rId1">
+            <a:lum/>
+          </a:blip>
+          <a:srcRect/>
+          <a:stretch>
+            <a:fillRect/>
+          </a:stretch>
+        </a:blipFill>
+        <a:effectLst/>
+      </p:bgPr>
+    </p:bg>
+    <p:spTree>
+      <p:nvGrpSpPr>
+        <p:cNvPr id="1" name=""/>
+        <p:cNvGrpSpPr/>
+        <p:nvPr/>
+      </p:nvGrpSpPr>
+      <p:grpSpPr>
+        <a:xfrm>
+          <a:off x="0" y="0"/>
+          <a:ext cx="0" cy="0"/>
+          <a:chOff x="0" y="0"/>
+          <a:chExt cx="0" cy="0"/>
+        </a:xfrm>
+      </p:grpSpPr>
+    </p:spTree>
+  </p:cSld>
+  <p:clrMapOvr>
+    <a:masterClrMapping/>
+  </p:clrMapOvr>
+</p:sld>
+</file>
+
 <file path=ppt/slides/slide2.xml><?xml version="1.0" encoding="utf-8"?>
 <p:sld xmlns:a="http://schemas.openxmlformats.org/drawingml/2006/main" xmlns:r="http://schemas.openxmlformats.org/officeDocument/2006/relationships" xmlns:p="http://schemas.openxmlformats.org/presentationml/2006/main">
   <p:cSld name="Slide 2">
+    <p:bg>
+      <p:bgPr>
+        <a:blipFill dpi="0" rotWithShape="1">
+          <a:blip r:embed="rId1">
+            <a:lum/>
+          </a:blip>
+          <a:srcRect/>
+          <a:stretch>
+            <a:fillRect/>
+          </a:stretch>
+        </a:blipFill>
+        <a:effectLst/>
+      </p:bgPr>
+    </p:bg>
+    <p:spTree>
+      <p:nvGrpSpPr>
+        <p:cNvPr id="1" name=""/>
+        <p:cNvGrpSpPr/>
+        <p:nvPr/>
+      </p:nvGrpSpPr>
+      <p:grpSpPr>
+        <a:xfrm>
+          <a:off x="0" y="0"/>
+          <a:ext cx="0" cy="0"/>
+          <a:chOff x="0" y="0"/>
+          <a:chExt cx="0" cy="0"/>
+        </a:xfrm>
+      </p:grpSpPr>
+    </p:spTree>
+  </p:cSld>
+  <p:clrMapOvr>
+    <a:masterClrMapping/>
+  </p:clrMapOvr>
+</p:sld>
+</file>
+
+<file path=ppt/slides/slide20.xml><?xml version="1.0" encoding="utf-8"?>
+<p:sld xmlns:a="http://schemas.openxmlformats.org/drawingml/2006/main" xmlns:r="http://schemas.openxmlformats.org/officeDocument/2006/relationships" xmlns:p="http://schemas.openxmlformats.org/presentationml/2006/main">
+  <p:cSld name="Slide 20">
+    <p:bg>
+      <p:bgPr>
+        <a:blipFill dpi="0" rotWithShape="1">
+          <a:blip r:embed="rId1">
+            <a:lum/>
+          </a:blip>
+          <a:srcRect/>
+          <a:stretch>
+            <a:fillRect/>
+          </a:stretch>
+        </a:blipFill>
+        <a:effectLst/>
+      </p:bgPr>
+    </p:bg>
+    <p:spTree>
+      <p:nvGrpSpPr>
+        <p:cNvPr id="1" name=""/>
+        <p:cNvGrpSpPr/>
+        <p:nvPr/>
+      </p:nvGrpSpPr>
+      <p:grpSpPr>
+        <a:xfrm>
+          <a:off x="0" y="0"/>
+          <a:ext cx="0" cy="0"/>
+          <a:chOff x="0" y="0"/>
+          <a:chExt cx="0" cy="0"/>
+        </a:xfrm>
+      </p:grpSpPr>
+    </p:spTree>
+  </p:cSld>
+  <p:clrMapOvr>
+    <a:masterClrMapping/>
+  </p:clrMapOvr>
+</p:sld>
+</file>
+
+<file path=ppt/slides/slide21.xml><?xml version="1.0" encoding="utf-8"?>
+<p:sld xmlns:a="http://schemas.openxmlformats.org/drawingml/2006/main" xmlns:r="http://schemas.openxmlformats.org/officeDocument/2006/relationships" xmlns:p="http://schemas.openxmlformats.org/presentationml/2006/main">
+  <p:cSld name="Slide 21">
+    <p:bg>
+      <p:bgPr>
+        <a:blipFill dpi="0" rotWithShape="1">
+          <a:blip r:embed="rId1">
+            <a:lum/>
+          </a:blip>
+          <a:srcRect/>
+          <a:stretch>
+            <a:fillRect/>
+          </a:stretch>
+        </a:blipFill>
+        <a:effectLst/>
+      </p:bgPr>
+    </p:bg>
+    <p:spTree>
+      <p:nvGrpSpPr>
+        <p:cNvPr id="1" name=""/>
+        <p:cNvGrpSpPr/>
+        <p:nvPr/>
+      </p:nvGrpSpPr>
+      <p:grpSpPr>
+        <a:xfrm>
+          <a:off x="0" y="0"/>
+          <a:ext cx="0" cy="0"/>
+          <a:chOff x="0" y="0"/>
+          <a:chExt cx="0" cy="0"/>
+        </a:xfrm>
+      </p:grpSpPr>
+    </p:spTree>
+  </p:cSld>
+  <p:clrMapOvr>
+    <a:masterClrMapping/>
+  </p:clrMapOvr>
+</p:sld>
+</file>
+
+<file path=ppt/slides/slide22.xml><?xml version="1.0" encoding="utf-8"?>
+<p:sld xmlns:a="http://schemas.openxmlformats.org/drawingml/2006/main" xmlns:r="http://schemas.openxmlformats.org/officeDocument/2006/relationships" xmlns:p="http://schemas.openxmlformats.org/presentationml/2006/main">
+  <p:cSld name="Slide 22">
+    <p:bg>
+      <p:bgPr>
+        <a:blipFill dpi="0" rotWithShape="1">
+          <a:blip r:embed="rId1">
+            <a:lum/>
+          </a:blip>
+          <a:srcRect/>
+          <a:stretch>
+            <a:fillRect/>
+          </a:stretch>
+        </a:blipFill>
+        <a:effectLst/>
+      </p:bgPr>
+    </p:bg>
+    <p:spTree>
+      <p:nvGrpSpPr>
+        <p:cNvPr id="1" name=""/>
+        <p:cNvGrpSpPr/>
+        <p:nvPr/>
+      </p:nvGrpSpPr>
+      <p:grpSpPr>
+        <a:xfrm>
+          <a:off x="0" y="0"/>
+          <a:ext cx="0" cy="0"/>
+          <a:chOff x="0" y="0"/>
+          <a:chExt cx="0" cy="0"/>
+        </a:xfrm>
+      </p:grpSpPr>
+    </p:spTree>
+  </p:cSld>
+  <p:clrMapOvr>
+    <a:masterClrMapping/>
+  </p:clrMapOvr>
+</p:sld>
+</file>
+
+<file path=ppt/slides/slide23.xml><?xml version="1.0" encoding="utf-8"?>
+<p:sld xmlns:a="http://schemas.openxmlformats.org/drawingml/2006/main" xmlns:r="http://schemas.openxmlformats.org/officeDocument/2006/relationships" xmlns:p="http://schemas.openxmlformats.org/presentationml/2006/main">
+  <p:cSld name="Slide 23">
     <p:bg>
       <p:bgPr>
         <a:blipFill dpi="0" rotWithShape="1">

</xml_diff>